<commit_message>
Added FieldValidatorAPI and understand how singleton property work
</commit_message>
<xml_diff>
--- a/Cycling Club Registration App Note.pptx
+++ b/Cycling Club Registration App Note.pptx
@@ -15,6 +15,9 @@
     <p:sldId id="263" r:id="rId9"/>
     <p:sldId id="264" r:id="rId10"/>
     <p:sldId id="265" r:id="rId11"/>
+    <p:sldId id="266" r:id="rId12"/>
+    <p:sldId id="267" r:id="rId13"/>
+    <p:sldId id="268" r:id="rId14"/>
   </p:sldIdLst>
   <p:sldSz cx="12192000" cy="6858000"/>
   <p:notesSz cx="6858000" cy="9144000"/>
@@ -113,6 +116,36 @@
       </a:defRPr>
     </a:lvl9pPr>
   </p:defaultTextStyle>
+  <p:extLst>
+    <p:ext uri="{521415D9-36F7-43E2-AB2F-B90AF26B5E84}">
+      <p14:sectionLst xmlns:p14="http://schemas.microsoft.com/office/powerpoint/2010/main">
+        <p14:section name="Default Section" id="{CBA6862B-9006-41A8-A5D2-85DF33C2D240}">
+          <p14:sldIdLst>
+            <p14:sldId id="256"/>
+            <p14:sldId id="257"/>
+            <p14:sldId id="259"/>
+            <p14:sldId id="258"/>
+            <p14:sldId id="260"/>
+            <p14:sldId id="261"/>
+            <p14:sldId id="262"/>
+            <p14:sldId id="263"/>
+            <p14:sldId id="264"/>
+            <p14:sldId id="265"/>
+          </p14:sldIdLst>
+        </p14:section>
+        <p14:section name="API" id="{F8AF0EA3-AE61-421F-80AF-1B2D9ECFBF10}">
+          <p14:sldIdLst>
+            <p14:sldId id="266"/>
+            <p14:sldId id="267"/>
+            <p14:sldId id="268"/>
+          </p14:sldIdLst>
+        </p14:section>
+      </p14:sectionLst>
+    </p:ext>
+    <p:ext uri="{EFAFB233-063F-42B5-8137-9DF3F51BA10A}">
+      <p15:sldGuideLst xmlns:p15="http://schemas.microsoft.com/office/powerpoint/2012/main"/>
+    </p:ext>
+  </p:extLst>
 </p:presentation>
 </file>
 
@@ -7957,6 +7990,663 @@
     <p:extLst>
       <p:ext uri="{BB962C8B-B14F-4D97-AF65-F5344CB8AC3E}">
         <p14:creationId xmlns:p14="http://schemas.microsoft.com/office/powerpoint/2010/main" val="2799312136"/>
+      </p:ext>
+    </p:extLst>
+  </p:cSld>
+  <p:clrMapOvr>
+    <a:masterClrMapping/>
+  </p:clrMapOvr>
+</p:sld>
+</file>
+
+<file path=ppt/slides/slide11.xml><?xml version="1.0" encoding="utf-8"?>
+<p:sld xmlns:a="http://schemas.openxmlformats.org/drawingml/2006/main" xmlns:r="http://schemas.openxmlformats.org/officeDocument/2006/relationships" xmlns:p="http://schemas.openxmlformats.org/presentationml/2006/main">
+  <p:cSld>
+    <p:spTree>
+      <p:nvGrpSpPr>
+        <p:cNvPr id="1" name=""/>
+        <p:cNvGrpSpPr/>
+        <p:nvPr/>
+      </p:nvGrpSpPr>
+      <p:grpSpPr>
+        <a:xfrm>
+          <a:off x="0" y="0"/>
+          <a:ext cx="0" cy="0"/>
+          <a:chOff x="0" y="0"/>
+          <a:chExt cx="0" cy="0"/>
+        </a:xfrm>
+      </p:grpSpPr>
+      <p:sp>
+        <p:nvSpPr>
+          <p:cNvPr id="2" name="Title 1">
+            <a:extLst>
+              <a:ext uri="{FF2B5EF4-FFF2-40B4-BE49-F238E27FC236}">
+                <a16:creationId xmlns:a16="http://schemas.microsoft.com/office/drawing/2014/main" id="{99854D5C-6E09-C344-E4DA-00A6A189DBF7}"/>
+              </a:ext>
+            </a:extLst>
+          </p:cNvPr>
+          <p:cNvSpPr>
+            <a:spLocks noGrp="1"/>
+          </p:cNvSpPr>
+          <p:nvPr>
+            <p:ph type="title"/>
+          </p:nvPr>
+        </p:nvSpPr>
+        <p:spPr/>
+        <p:txBody>
+          <a:bodyPr>
+            <a:normAutofit/>
+          </a:bodyPr>
+          <a:lstStyle/>
+          <a:p>
+            <a:r>
+              <a:rPr lang="en-US" dirty="0" err="1"/>
+              <a:t>FieldValidatorAPI</a:t>
+            </a:r>
+            <a:r>
+              <a:rPr lang="en-US" dirty="0"/>
+              <a:t> – </a:t>
+            </a:r>
+            <a:r>
+              <a:rPr lang="en-US" dirty="0" err="1"/>
+              <a:t>CommonFiledValidatorFunctions</a:t>
+            </a:r>
+            <a:endParaRPr lang="en-US" dirty="0"/>
+          </a:p>
+        </p:txBody>
+      </p:sp>
+      <p:pic>
+        <p:nvPicPr>
+          <p:cNvPr id="5" name="Content Placeholder 4">
+            <a:extLst>
+              <a:ext uri="{FF2B5EF4-FFF2-40B4-BE49-F238E27FC236}">
+                <a16:creationId xmlns:a16="http://schemas.microsoft.com/office/drawing/2014/main" id="{C7B708FC-FDF5-194D-2B2E-2D262C69E65D}"/>
+              </a:ext>
+            </a:extLst>
+          </p:cNvPr>
+          <p:cNvPicPr>
+            <a:picLocks noGrp="1" noChangeAspect="1"/>
+          </p:cNvPicPr>
+          <p:nvPr>
+            <p:ph idx="1"/>
+          </p:nvPr>
+        </p:nvPicPr>
+        <p:blipFill>
+          <a:blip r:embed="rId2"/>
+          <a:stretch>
+            <a:fillRect/>
+          </a:stretch>
+        </p:blipFill>
+        <p:spPr>
+          <a:xfrm>
+            <a:off x="3341688" y="3455987"/>
+            <a:ext cx="7410450" cy="1133475"/>
+          </a:xfrm>
+        </p:spPr>
+      </p:pic>
+      <p:sp>
+        <p:nvSpPr>
+          <p:cNvPr id="6" name="Speech Bubble: Rectangle with Corners Rounded 5">
+            <a:extLst>
+              <a:ext uri="{FF2B5EF4-FFF2-40B4-BE49-F238E27FC236}">
+                <a16:creationId xmlns:a16="http://schemas.microsoft.com/office/drawing/2014/main" id="{5D6BB7E6-F863-DE4A-CA1B-A12251838DD2}"/>
+              </a:ext>
+            </a:extLst>
+          </p:cNvPr>
+          <p:cNvSpPr/>
+          <p:nvPr/>
+        </p:nvSpPr>
+        <p:spPr>
+          <a:xfrm>
+            <a:off x="3341688" y="2726389"/>
+            <a:ext cx="6229602" cy="383137"/>
+          </a:xfrm>
+          <a:prstGeom prst="wedgeRoundRectCallout">
+            <a:avLst>
+              <a:gd name="adj1" fmla="val 1910"/>
+              <a:gd name="adj2" fmla="val 179282"/>
+              <a:gd name="adj3" fmla="val 16667"/>
+            </a:avLst>
+          </a:prstGeom>
+        </p:spPr>
+        <p:style>
+          <a:lnRef idx="2">
+            <a:schemeClr val="accent1">
+              <a:shade val="15000"/>
+            </a:schemeClr>
+          </a:lnRef>
+          <a:fillRef idx="1">
+            <a:schemeClr val="accent1"/>
+          </a:fillRef>
+          <a:effectRef idx="0">
+            <a:schemeClr val="accent1"/>
+          </a:effectRef>
+          <a:fontRef idx="minor">
+            <a:schemeClr val="lt1"/>
+          </a:fontRef>
+        </p:style>
+        <p:txBody>
+          <a:bodyPr rtlCol="0" anchor="ctr"/>
+          <a:lstStyle/>
+          <a:p>
+            <a:pPr algn="ctr"/>
+            <a:r>
+              <a:rPr lang="en-US" sz="1000" dirty="0"/>
+              <a:t>This delegate can reference any method that take a single string parameter and return bool</a:t>
+            </a:r>
+          </a:p>
+        </p:txBody>
+      </p:sp>
+      <p:sp>
+        <p:nvSpPr>
+          <p:cNvPr id="8" name="TextBox 7">
+            <a:extLst>
+              <a:ext uri="{FF2B5EF4-FFF2-40B4-BE49-F238E27FC236}">
+                <a16:creationId xmlns:a16="http://schemas.microsoft.com/office/drawing/2014/main" id="{F5954640-D2C0-E61A-6C30-93BEC0805312}"/>
+              </a:ext>
+            </a:extLst>
+          </p:cNvPr>
+          <p:cNvSpPr txBox="1"/>
+          <p:nvPr/>
+        </p:nvSpPr>
+        <p:spPr>
+          <a:xfrm>
+            <a:off x="5877371" y="4660513"/>
+            <a:ext cx="2540237" cy="369332"/>
+          </a:xfrm>
+          <a:prstGeom prst="rect">
+            <a:avLst/>
+          </a:prstGeom>
+          <a:noFill/>
+        </p:spPr>
+        <p:txBody>
+          <a:bodyPr wrap="square">
+            <a:spAutoFit/>
+          </a:bodyPr>
+          <a:lstStyle/>
+          <a:p>
+            <a:r>
+              <a:rPr lang="en-US" dirty="0"/>
+              <a:t>Delegate Definitions</a:t>
+            </a:r>
+          </a:p>
+        </p:txBody>
+      </p:sp>
+    </p:spTree>
+    <p:extLst>
+      <p:ext uri="{BB962C8B-B14F-4D97-AF65-F5344CB8AC3E}">
+        <p14:creationId xmlns:p14="http://schemas.microsoft.com/office/powerpoint/2010/main" val="3146982589"/>
+      </p:ext>
+    </p:extLst>
+  </p:cSld>
+  <p:clrMapOvr>
+    <a:masterClrMapping/>
+  </p:clrMapOvr>
+</p:sld>
+</file>
+
+<file path=ppt/slides/slide12.xml><?xml version="1.0" encoding="utf-8"?>
+<p:sld xmlns:a="http://schemas.openxmlformats.org/drawingml/2006/main" xmlns:r="http://schemas.openxmlformats.org/officeDocument/2006/relationships" xmlns:p="http://schemas.openxmlformats.org/presentationml/2006/main">
+  <p:cSld>
+    <p:spTree>
+      <p:nvGrpSpPr>
+        <p:cNvPr id="1" name=""/>
+        <p:cNvGrpSpPr/>
+        <p:nvPr/>
+      </p:nvGrpSpPr>
+      <p:grpSpPr>
+        <a:xfrm>
+          <a:off x="0" y="0"/>
+          <a:ext cx="0" cy="0"/>
+          <a:chOff x="0" y="0"/>
+          <a:chExt cx="0" cy="0"/>
+        </a:xfrm>
+      </p:grpSpPr>
+      <p:sp>
+        <p:nvSpPr>
+          <p:cNvPr id="2" name="Title 1">
+            <a:extLst>
+              <a:ext uri="{FF2B5EF4-FFF2-40B4-BE49-F238E27FC236}">
+                <a16:creationId xmlns:a16="http://schemas.microsoft.com/office/drawing/2014/main" id="{98BC3FAE-37CE-59B3-16A7-7D9E9C137DA1}"/>
+              </a:ext>
+            </a:extLst>
+          </p:cNvPr>
+          <p:cNvSpPr>
+            <a:spLocks noGrp="1"/>
+          </p:cNvSpPr>
+          <p:nvPr>
+            <p:ph type="title"/>
+          </p:nvPr>
+        </p:nvSpPr>
+        <p:spPr/>
+        <p:txBody>
+          <a:bodyPr/>
+          <a:lstStyle/>
+          <a:p>
+            <a:r>
+              <a:rPr lang="en-US" dirty="0" err="1"/>
+              <a:t>FieldValidatorAPI</a:t>
+            </a:r>
+            <a:r>
+              <a:rPr lang="en-US" dirty="0"/>
+              <a:t> – </a:t>
+            </a:r>
+            <a:r>
+              <a:rPr lang="en-US" dirty="0" err="1"/>
+              <a:t>CommonFiledValidatorFunctions</a:t>
+            </a:r>
+            <a:endParaRPr lang="en-US" dirty="0"/>
+          </a:p>
+        </p:txBody>
+      </p:sp>
+      <p:pic>
+        <p:nvPicPr>
+          <p:cNvPr id="5" name="Content Placeholder 4">
+            <a:extLst>
+              <a:ext uri="{FF2B5EF4-FFF2-40B4-BE49-F238E27FC236}">
+                <a16:creationId xmlns:a16="http://schemas.microsoft.com/office/drawing/2014/main" id="{FEDD9420-7FE9-4C64-9255-6D7FC3104395}"/>
+              </a:ext>
+            </a:extLst>
+          </p:cNvPr>
+          <p:cNvPicPr>
+            <a:picLocks noGrp="1" noChangeAspect="1"/>
+          </p:cNvPicPr>
+          <p:nvPr>
+            <p:ph idx="1"/>
+          </p:nvPr>
+        </p:nvPicPr>
+        <p:blipFill>
+          <a:blip r:embed="rId2"/>
+          <a:stretch>
+            <a:fillRect/>
+          </a:stretch>
+        </p:blipFill>
+        <p:spPr>
+          <a:xfrm>
+            <a:off x="4880364" y="2133600"/>
+            <a:ext cx="4333097" cy="3778250"/>
+          </a:xfrm>
+        </p:spPr>
+      </p:pic>
+      <p:sp>
+        <p:nvSpPr>
+          <p:cNvPr id="6" name="TextBox 5">
+            <a:extLst>
+              <a:ext uri="{FF2B5EF4-FFF2-40B4-BE49-F238E27FC236}">
+                <a16:creationId xmlns:a16="http://schemas.microsoft.com/office/drawing/2014/main" id="{C5104764-BDA6-9FA3-0DFB-0B70D38277C4}"/>
+              </a:ext>
+            </a:extLst>
+          </p:cNvPr>
+          <p:cNvSpPr txBox="1"/>
+          <p:nvPr/>
+        </p:nvSpPr>
+        <p:spPr>
+          <a:xfrm>
+            <a:off x="4153258" y="5898764"/>
+            <a:ext cx="6272612" cy="369332"/>
+          </a:xfrm>
+          <a:prstGeom prst="rect">
+            <a:avLst/>
+          </a:prstGeom>
+          <a:noFill/>
+        </p:spPr>
+        <p:txBody>
+          <a:bodyPr wrap="square">
+            <a:spAutoFit/>
+          </a:bodyPr>
+          <a:lstStyle/>
+          <a:p>
+            <a:r>
+              <a:rPr lang="en-US" dirty="0"/>
+              <a:t>Methods that implement the actual validation logic</a:t>
+            </a:r>
+          </a:p>
+        </p:txBody>
+      </p:sp>
+    </p:spTree>
+    <p:extLst>
+      <p:ext uri="{BB962C8B-B14F-4D97-AF65-F5344CB8AC3E}">
+        <p14:creationId xmlns:p14="http://schemas.microsoft.com/office/powerpoint/2010/main" val="2857647084"/>
+      </p:ext>
+    </p:extLst>
+  </p:cSld>
+  <p:clrMapOvr>
+    <a:masterClrMapping/>
+  </p:clrMapOvr>
+</p:sld>
+</file>
+
+<file path=ppt/slides/slide13.xml><?xml version="1.0" encoding="utf-8"?>
+<p:sld xmlns:a="http://schemas.openxmlformats.org/drawingml/2006/main" xmlns:r="http://schemas.openxmlformats.org/officeDocument/2006/relationships" xmlns:p="http://schemas.openxmlformats.org/presentationml/2006/main">
+  <p:cSld>
+    <p:spTree>
+      <p:nvGrpSpPr>
+        <p:cNvPr id="1" name=""/>
+        <p:cNvGrpSpPr/>
+        <p:nvPr/>
+      </p:nvGrpSpPr>
+      <p:grpSpPr>
+        <a:xfrm>
+          <a:off x="0" y="0"/>
+          <a:ext cx="0" cy="0"/>
+          <a:chOff x="0" y="0"/>
+          <a:chExt cx="0" cy="0"/>
+        </a:xfrm>
+      </p:grpSpPr>
+      <p:sp>
+        <p:nvSpPr>
+          <p:cNvPr id="2" name="Title 1">
+            <a:extLst>
+              <a:ext uri="{FF2B5EF4-FFF2-40B4-BE49-F238E27FC236}">
+                <a16:creationId xmlns:a16="http://schemas.microsoft.com/office/drawing/2014/main" id="{939FAF2B-0DED-AC89-BA0F-CCCE11B962E0}"/>
+              </a:ext>
+            </a:extLst>
+          </p:cNvPr>
+          <p:cNvSpPr>
+            <a:spLocks noGrp="1"/>
+          </p:cNvSpPr>
+          <p:nvPr>
+            <p:ph type="title"/>
+          </p:nvPr>
+        </p:nvSpPr>
+        <p:spPr/>
+        <p:txBody>
+          <a:bodyPr/>
+          <a:lstStyle/>
+          <a:p>
+            <a:r>
+              <a:rPr lang="en-US" dirty="0" err="1"/>
+              <a:t>FieldValidatorAPI</a:t>
+            </a:r>
+            <a:r>
+              <a:rPr lang="en-US" dirty="0"/>
+              <a:t> –</a:t>
+            </a:r>
+            <a:br>
+              <a:rPr lang="en-US" dirty="0"/>
+            </a:br>
+            <a:r>
+              <a:rPr lang="en-US" dirty="0" err="1"/>
+              <a:t>CommonFiledValidatorFunctions</a:t>
+            </a:r>
+            <a:endParaRPr lang="en-US" dirty="0"/>
+          </a:p>
+        </p:txBody>
+      </p:sp>
+      <p:pic>
+        <p:nvPicPr>
+          <p:cNvPr id="5" name="Content Placeholder 4">
+            <a:extLst>
+              <a:ext uri="{FF2B5EF4-FFF2-40B4-BE49-F238E27FC236}">
+                <a16:creationId xmlns:a16="http://schemas.microsoft.com/office/drawing/2014/main" id="{BF71FC70-D2EF-9C0B-46F1-15DEA3758A68}"/>
+              </a:ext>
+            </a:extLst>
+          </p:cNvPr>
+          <p:cNvPicPr>
+            <a:picLocks noGrp="1" noChangeAspect="1"/>
+          </p:cNvPicPr>
+          <p:nvPr>
+            <p:ph idx="1"/>
+          </p:nvPr>
+        </p:nvPicPr>
+        <p:blipFill>
+          <a:blip r:embed="rId2"/>
+          <a:stretch>
+            <a:fillRect/>
+          </a:stretch>
+        </p:blipFill>
+        <p:spPr>
+          <a:xfrm>
+            <a:off x="2731492" y="3960406"/>
+            <a:ext cx="7048500" cy="1485900"/>
+          </a:xfrm>
+        </p:spPr>
+      </p:pic>
+      <p:pic>
+        <p:nvPicPr>
+          <p:cNvPr id="7" name="Picture 6">
+            <a:extLst>
+              <a:ext uri="{FF2B5EF4-FFF2-40B4-BE49-F238E27FC236}">
+                <a16:creationId xmlns:a16="http://schemas.microsoft.com/office/drawing/2014/main" id="{9D44AFC9-58A3-C846-C3C8-DDEC9A678F24}"/>
+              </a:ext>
+            </a:extLst>
+          </p:cNvPr>
+          <p:cNvPicPr>
+            <a:picLocks noChangeAspect="1"/>
+          </p:cNvPicPr>
+          <p:nvPr/>
+        </p:nvPicPr>
+        <p:blipFill>
+          <a:blip r:embed="rId3"/>
+          <a:stretch>
+            <a:fillRect/>
+          </a:stretch>
+        </p:blipFill>
+        <p:spPr>
+          <a:xfrm>
+            <a:off x="2765676" y="2363839"/>
+            <a:ext cx="5686425" cy="209550"/>
+          </a:xfrm>
+          <a:prstGeom prst="rect">
+            <a:avLst/>
+          </a:prstGeom>
+        </p:spPr>
+      </p:pic>
+      <p:sp>
+        <p:nvSpPr>
+          <p:cNvPr id="8" name="Speech Bubble: Rectangle with Corners Rounded 7">
+            <a:extLst>
+              <a:ext uri="{FF2B5EF4-FFF2-40B4-BE49-F238E27FC236}">
+                <a16:creationId xmlns:a16="http://schemas.microsoft.com/office/drawing/2014/main" id="{EF4C1DD6-AB05-85F8-93F9-9E3C9A5D5C55}"/>
+              </a:ext>
+            </a:extLst>
+          </p:cNvPr>
+          <p:cNvSpPr/>
+          <p:nvPr/>
+        </p:nvSpPr>
+        <p:spPr>
+          <a:xfrm>
+            <a:off x="7734225" y="1905786"/>
+            <a:ext cx="1734514" cy="383137"/>
+          </a:xfrm>
+          <a:prstGeom prst="wedgeRoundRectCallout">
+            <a:avLst>
+              <a:gd name="adj1" fmla="val -70230"/>
+              <a:gd name="adj2" fmla="val 67758"/>
+              <a:gd name="adj3" fmla="val 16667"/>
+            </a:avLst>
+          </a:prstGeom>
+        </p:spPr>
+        <p:style>
+          <a:lnRef idx="2">
+            <a:schemeClr val="accent1">
+              <a:shade val="15000"/>
+            </a:schemeClr>
+          </a:lnRef>
+          <a:fillRef idx="1">
+            <a:schemeClr val="accent1"/>
+          </a:fillRef>
+          <a:effectRef idx="0">
+            <a:schemeClr val="accent1"/>
+          </a:effectRef>
+          <a:fontRef idx="minor">
+            <a:schemeClr val="lt1"/>
+          </a:fontRef>
+        </p:style>
+        <p:txBody>
+          <a:bodyPr rtlCol="0" anchor="ctr"/>
+          <a:lstStyle/>
+          <a:p>
+            <a:pPr algn="ctr"/>
+            <a:r>
+              <a:rPr lang="en-US" sz="1000" dirty="0"/>
+              <a:t>The reference (variable)</a:t>
+            </a:r>
+          </a:p>
+        </p:txBody>
+      </p:sp>
+      <p:sp>
+        <p:nvSpPr>
+          <p:cNvPr id="9" name="TextBox 8">
+            <a:extLst>
+              <a:ext uri="{FF2B5EF4-FFF2-40B4-BE49-F238E27FC236}">
+                <a16:creationId xmlns:a16="http://schemas.microsoft.com/office/drawing/2014/main" id="{0893F62E-3781-1025-AB4F-FCF16F261F79}"/>
+              </a:ext>
+            </a:extLst>
+          </p:cNvPr>
+          <p:cNvSpPr txBox="1"/>
+          <p:nvPr/>
+        </p:nvSpPr>
+        <p:spPr>
+          <a:xfrm>
+            <a:off x="2731491" y="5446306"/>
+            <a:ext cx="9044613" cy="1200329"/>
+          </a:xfrm>
+          <a:prstGeom prst="rect">
+            <a:avLst/>
+          </a:prstGeom>
+          <a:noFill/>
+        </p:spPr>
+        <p:txBody>
+          <a:bodyPr wrap="square">
+            <a:spAutoFit/>
+          </a:bodyPr>
+          <a:lstStyle/>
+          <a:p>
+            <a:r>
+              <a:rPr lang="en-US" dirty="0"/>
+              <a:t>Lazy initialization of the delegate instance.</a:t>
+            </a:r>
+            <a:br>
+              <a:rPr lang="en-US" dirty="0"/>
+            </a:br>
+            <a:r>
+              <a:rPr lang="en-US" dirty="0"/>
+              <a:t>This approach also known as Singleton as it only ONE instance created.</a:t>
+            </a:r>
+            <a:br>
+              <a:rPr lang="en-US" dirty="0"/>
+            </a:br>
+            <a:r>
+              <a:rPr lang="en-US" dirty="0"/>
+              <a:t>Thus, it always return the instance which is created at first time. </a:t>
+            </a:r>
+          </a:p>
+          <a:p>
+            <a:endParaRPr lang="en-US" dirty="0"/>
+          </a:p>
+        </p:txBody>
+      </p:sp>
+      <p:sp>
+        <p:nvSpPr>
+          <p:cNvPr id="10" name="Speech Bubble: Rectangle with Corners Rounded 9">
+            <a:extLst>
+              <a:ext uri="{FF2B5EF4-FFF2-40B4-BE49-F238E27FC236}">
+                <a16:creationId xmlns:a16="http://schemas.microsoft.com/office/drawing/2014/main" id="{77D99C2A-D3D0-5D40-B04E-8AA819E0178D}"/>
+              </a:ext>
+            </a:extLst>
+          </p:cNvPr>
+          <p:cNvSpPr/>
+          <p:nvPr/>
+        </p:nvSpPr>
+        <p:spPr>
+          <a:xfrm>
+            <a:off x="3810280" y="2725581"/>
+            <a:ext cx="5897742" cy="465222"/>
+          </a:xfrm>
+          <a:prstGeom prst="wedgeRoundRectCallout">
+            <a:avLst>
+              <a:gd name="adj1" fmla="val -63343"/>
+              <a:gd name="adj2" fmla="val -86538"/>
+              <a:gd name="adj3" fmla="val 16667"/>
+            </a:avLst>
+          </a:prstGeom>
+        </p:spPr>
+        <p:style>
+          <a:lnRef idx="2">
+            <a:schemeClr val="accent1">
+              <a:shade val="15000"/>
+            </a:schemeClr>
+          </a:lnRef>
+          <a:fillRef idx="1">
+            <a:schemeClr val="accent1"/>
+          </a:fillRef>
+          <a:effectRef idx="0">
+            <a:schemeClr val="accent1"/>
+          </a:effectRef>
+          <a:fontRef idx="minor">
+            <a:schemeClr val="lt1"/>
+          </a:fontRef>
+        </p:style>
+        <p:txBody>
+          <a:bodyPr rtlCol="0" anchor="ctr"/>
+          <a:lstStyle/>
+          <a:p>
+            <a:pPr algn="ctr"/>
+            <a:r>
+              <a:rPr lang="en-US" sz="1000" dirty="0"/>
+              <a:t>Prevent the user from pointing the delegate to other function and only use the function controlled in get property.</a:t>
+            </a:r>
+          </a:p>
+        </p:txBody>
+      </p:sp>
+      <p:sp>
+        <p:nvSpPr>
+          <p:cNvPr id="13" name="Speech Bubble: Rectangle with Corners Rounded 12">
+            <a:extLst>
+              <a:ext uri="{FF2B5EF4-FFF2-40B4-BE49-F238E27FC236}">
+                <a16:creationId xmlns:a16="http://schemas.microsoft.com/office/drawing/2014/main" id="{5EC4BB04-354F-4E5A-26F3-B23E95422A84}"/>
+              </a:ext>
+            </a:extLst>
+          </p:cNvPr>
+          <p:cNvSpPr/>
+          <p:nvPr/>
+        </p:nvSpPr>
+        <p:spPr>
+          <a:xfrm>
+            <a:off x="484823" y="3425078"/>
+            <a:ext cx="3325457" cy="383137"/>
+          </a:xfrm>
+          <a:prstGeom prst="wedgeRoundRectCallout">
+            <a:avLst>
+              <a:gd name="adj1" fmla="val 56628"/>
+              <a:gd name="adj2" fmla="val 94522"/>
+              <a:gd name="adj3" fmla="val 16667"/>
+            </a:avLst>
+          </a:prstGeom>
+        </p:spPr>
+        <p:style>
+          <a:lnRef idx="2">
+            <a:schemeClr val="accent1">
+              <a:shade val="15000"/>
+            </a:schemeClr>
+          </a:lnRef>
+          <a:fillRef idx="1">
+            <a:schemeClr val="accent1"/>
+          </a:fillRef>
+          <a:effectRef idx="0">
+            <a:schemeClr val="accent1"/>
+          </a:effectRef>
+          <a:fontRef idx="minor">
+            <a:schemeClr val="lt1"/>
+          </a:fontRef>
+        </p:style>
+        <p:txBody>
+          <a:bodyPr rtlCol="0" anchor="ctr"/>
+          <a:lstStyle/>
+          <a:p>
+            <a:pPr algn="ctr"/>
+            <a:r>
+              <a:rPr lang="en-US" sz="1000" dirty="0"/>
+              <a:t>Lazy Loading: only create the instance when someone calls the get for the first time.</a:t>
+            </a:r>
+          </a:p>
+        </p:txBody>
+      </p:sp>
+    </p:spTree>
+    <p:extLst>
+      <p:ext uri="{BB962C8B-B14F-4D97-AF65-F5344CB8AC3E}">
+        <p14:creationId xmlns:p14="http://schemas.microsoft.com/office/powerpoint/2010/main" val="491318003"/>
       </p:ext>
     </p:extLst>
   </p:cSld>

</xml_diff>

<commit_message>
Complete the development. Note still on going.
</commit_message>
<xml_diff>
--- a/Cycling Club Registration App Note.pptx
+++ b/Cycling Club Registration App Note.pptx
@@ -18,6 +18,11 @@
     <p:sldId id="266" r:id="rId12"/>
     <p:sldId id="267" r:id="rId13"/>
     <p:sldId id="268" r:id="rId14"/>
+    <p:sldId id="269" r:id="rId15"/>
+    <p:sldId id="270" r:id="rId16"/>
+    <p:sldId id="271" r:id="rId17"/>
+    <p:sldId id="272" r:id="rId18"/>
+    <p:sldId id="273" r:id="rId19"/>
   </p:sldIdLst>
   <p:sldSz cx="12192000" cy="6858000"/>
   <p:notesSz cx="6858000" cy="9144000"/>
@@ -138,6 +143,11 @@
             <p14:sldId id="266"/>
             <p14:sldId id="267"/>
             <p14:sldId id="268"/>
+            <p14:sldId id="269"/>
+            <p14:sldId id="270"/>
+            <p14:sldId id="271"/>
+            <p14:sldId id="272"/>
+            <p14:sldId id="273"/>
           </p14:sldIdLst>
         </p14:section>
       </p14:sectionLst>
@@ -337,7 +347,7 @@
           <a:p>
             <a:fld id="{2F32F0BC-95FF-4EBB-823D-AD073BC23E54}" type="datetimeFigureOut">
               <a:rPr lang="en-US" smtClean="0"/>
-              <a:t>3/12/2026</a:t>
+              <a:t>3/13/2026</a:t>
             </a:fld>
             <a:endParaRPr lang="en-US"/>
           </a:p>
@@ -675,7 +685,7 @@
           <a:p>
             <a:fld id="{2F32F0BC-95FF-4EBB-823D-AD073BC23E54}" type="datetimeFigureOut">
               <a:rPr lang="en-US" smtClean="0"/>
-              <a:t>3/12/2026</a:t>
+              <a:t>3/13/2026</a:t>
             </a:fld>
             <a:endParaRPr lang="en-US"/>
           </a:p>
@@ -1076,7 +1086,7 @@
           <a:p>
             <a:fld id="{2F32F0BC-95FF-4EBB-823D-AD073BC23E54}" type="datetimeFigureOut">
               <a:rPr lang="en-US" smtClean="0"/>
-              <a:t>3/12/2026</a:t>
+              <a:t>3/13/2026</a:t>
             </a:fld>
             <a:endParaRPr lang="en-US"/>
           </a:p>
@@ -1412,7 +1422,7 @@
           <a:p>
             <a:fld id="{2F32F0BC-95FF-4EBB-823D-AD073BC23E54}" type="datetimeFigureOut">
               <a:rPr lang="en-US" smtClean="0"/>
-              <a:t>3/12/2026</a:t>
+              <a:t>3/13/2026</a:t>
             </a:fld>
             <a:endParaRPr lang="en-US"/>
           </a:p>
@@ -1732,7 +1742,7 @@
           <a:p>
             <a:fld id="{2F32F0BC-95FF-4EBB-823D-AD073BC23E54}" type="datetimeFigureOut">
               <a:rPr lang="en-US" smtClean="0"/>
-              <a:t>3/12/2026</a:t>
+              <a:t>3/13/2026</a:t>
             </a:fld>
             <a:endParaRPr lang="en-US"/>
           </a:p>
@@ -2128,7 +2138,7 @@
           <a:p>
             <a:fld id="{2F32F0BC-95FF-4EBB-823D-AD073BC23E54}" type="datetimeFigureOut">
               <a:rPr lang="en-US" smtClean="0"/>
-              <a:t>3/12/2026</a:t>
+              <a:t>3/13/2026</a:t>
             </a:fld>
             <a:endParaRPr lang="en-US"/>
           </a:p>
@@ -2385,7 +2395,7 @@
           <a:p>
             <a:fld id="{2F32F0BC-95FF-4EBB-823D-AD073BC23E54}" type="datetimeFigureOut">
               <a:rPr lang="en-US" smtClean="0"/>
-              <a:t>3/12/2026</a:t>
+              <a:t>3/13/2026</a:t>
             </a:fld>
             <a:endParaRPr lang="en-US"/>
           </a:p>
@@ -2647,7 +2657,7 @@
           <a:p>
             <a:fld id="{2F32F0BC-95FF-4EBB-823D-AD073BC23E54}" type="datetimeFigureOut">
               <a:rPr lang="en-US" smtClean="0"/>
-              <a:t>3/12/2026</a:t>
+              <a:t>3/13/2026</a:t>
             </a:fld>
             <a:endParaRPr lang="en-US"/>
           </a:p>
@@ -2909,7 +2919,7 @@
           <a:p>
             <a:fld id="{2F32F0BC-95FF-4EBB-823D-AD073BC23E54}" type="datetimeFigureOut">
               <a:rPr lang="en-US" smtClean="0"/>
-              <a:t>3/12/2026</a:t>
+              <a:t>3/13/2026</a:t>
             </a:fld>
             <a:endParaRPr lang="en-US"/>
           </a:p>
@@ -3238,7 +3248,7 @@
           <a:p>
             <a:fld id="{2F32F0BC-95FF-4EBB-823D-AD073BC23E54}" type="datetimeFigureOut">
               <a:rPr lang="en-US" smtClean="0"/>
-              <a:t>3/12/2026</a:t>
+              <a:t>3/13/2026</a:t>
             </a:fld>
             <a:endParaRPr lang="en-US"/>
           </a:p>
@@ -3561,7 +3571,7 @@
           <a:p>
             <a:fld id="{2F32F0BC-95FF-4EBB-823D-AD073BC23E54}" type="datetimeFigureOut">
               <a:rPr lang="en-US" smtClean="0"/>
-              <a:t>3/12/2026</a:t>
+              <a:t>3/13/2026</a:t>
             </a:fld>
             <a:endParaRPr lang="en-US"/>
           </a:p>
@@ -4018,7 +4028,7 @@
           <a:p>
             <a:fld id="{2F32F0BC-95FF-4EBB-823D-AD073BC23E54}" type="datetimeFigureOut">
               <a:rPr lang="en-US" smtClean="0"/>
-              <a:t>3/12/2026</a:t>
+              <a:t>3/13/2026</a:t>
             </a:fld>
             <a:endParaRPr lang="en-US"/>
           </a:p>
@@ -4223,7 +4233,7 @@
           <a:p>
             <a:fld id="{2F32F0BC-95FF-4EBB-823D-AD073BC23E54}" type="datetimeFigureOut">
               <a:rPr lang="en-US" smtClean="0"/>
-              <a:t>3/12/2026</a:t>
+              <a:t>3/13/2026</a:t>
             </a:fld>
             <a:endParaRPr lang="en-US"/>
           </a:p>
@@ -4400,7 +4410,7 @@
           <a:p>
             <a:fld id="{2F32F0BC-95FF-4EBB-823D-AD073BC23E54}" type="datetimeFigureOut">
               <a:rPr lang="en-US" smtClean="0"/>
-              <a:t>3/12/2026</a:t>
+              <a:t>3/13/2026</a:t>
             </a:fld>
             <a:endParaRPr lang="en-US"/>
           </a:p>
@@ -4733,7 +4743,7 @@
           <a:p>
             <a:fld id="{2F32F0BC-95FF-4EBB-823D-AD073BC23E54}" type="datetimeFigureOut">
               <a:rPr lang="en-US" smtClean="0"/>
-              <a:t>3/12/2026</a:t>
+              <a:t>3/13/2026</a:t>
             </a:fld>
             <a:endParaRPr lang="en-US"/>
           </a:p>
@@ -5078,7 +5088,7 @@
           <a:p>
             <a:fld id="{2F32F0BC-95FF-4EBB-823D-AD073BC23E54}" type="datetimeFigureOut">
               <a:rPr lang="en-US" smtClean="0"/>
-              <a:t>3/12/2026</a:t>
+              <a:t>3/13/2026</a:t>
             </a:fld>
             <a:endParaRPr lang="en-US"/>
           </a:p>
@@ -7195,7 +7205,7 @@
           <a:p>
             <a:fld id="{2F32F0BC-95FF-4EBB-823D-AD073BC23E54}" type="datetimeFigureOut">
               <a:rPr lang="en-US" smtClean="0"/>
-              <a:t>3/12/2026</a:t>
+              <a:t>3/13/2026</a:t>
             </a:fld>
             <a:endParaRPr lang="en-US"/>
           </a:p>
@@ -8643,10 +8653,1297 @@
           </a:p>
         </p:txBody>
       </p:sp>
+      <p:sp>
+        <p:nvSpPr>
+          <p:cNvPr id="3" name="Speech Bubble: Rectangle with Corners Rounded 2">
+            <a:extLst>
+              <a:ext uri="{FF2B5EF4-FFF2-40B4-BE49-F238E27FC236}">
+                <a16:creationId xmlns:a16="http://schemas.microsoft.com/office/drawing/2014/main" id="{A4BCC9CB-1E27-EC9D-7DFB-E034079CB1EE}"/>
+              </a:ext>
+            </a:extLst>
+          </p:cNvPr>
+          <p:cNvSpPr/>
+          <p:nvPr/>
+        </p:nvSpPr>
+        <p:spPr>
+          <a:xfrm>
+            <a:off x="9064664" y="4152760"/>
+            <a:ext cx="1286715" cy="383137"/>
+          </a:xfrm>
+          <a:prstGeom prst="wedgeRoundRectCallout">
+            <a:avLst>
+              <a:gd name="adj1" fmla="val -49637"/>
+              <a:gd name="adj2" fmla="val 103444"/>
+              <a:gd name="adj3" fmla="val 16667"/>
+            </a:avLst>
+          </a:prstGeom>
+        </p:spPr>
+        <p:style>
+          <a:lnRef idx="2">
+            <a:schemeClr val="accent1">
+              <a:shade val="15000"/>
+            </a:schemeClr>
+          </a:lnRef>
+          <a:fillRef idx="1">
+            <a:schemeClr val="accent1"/>
+          </a:fillRef>
+          <a:effectRef idx="0">
+            <a:schemeClr val="accent1"/>
+          </a:effectRef>
+          <a:fontRef idx="minor">
+            <a:schemeClr val="lt1"/>
+          </a:fontRef>
+        </p:style>
+        <p:txBody>
+          <a:bodyPr rtlCol="0" anchor="ctr"/>
+          <a:lstStyle/>
+          <a:p>
+            <a:pPr algn="ctr"/>
+            <a:r>
+              <a:rPr lang="en-US" sz="1000" dirty="0"/>
+              <a:t>The method</a:t>
+            </a:r>
+          </a:p>
+        </p:txBody>
+      </p:sp>
     </p:spTree>
     <p:extLst>
       <p:ext uri="{BB962C8B-B14F-4D97-AF65-F5344CB8AC3E}">
         <p14:creationId xmlns:p14="http://schemas.microsoft.com/office/powerpoint/2010/main" val="491318003"/>
+      </p:ext>
+    </p:extLst>
+  </p:cSld>
+  <p:clrMapOvr>
+    <a:masterClrMapping/>
+  </p:clrMapOvr>
+</p:sld>
+</file>
+
+<file path=ppt/slides/slide14.xml><?xml version="1.0" encoding="utf-8"?>
+<p:sld xmlns:a="http://schemas.openxmlformats.org/drawingml/2006/main" xmlns:r="http://schemas.openxmlformats.org/officeDocument/2006/relationships" xmlns:p="http://schemas.openxmlformats.org/presentationml/2006/main">
+  <p:cSld>
+    <p:spTree>
+      <p:nvGrpSpPr>
+        <p:cNvPr id="1" name=""/>
+        <p:cNvGrpSpPr/>
+        <p:nvPr/>
+      </p:nvGrpSpPr>
+      <p:grpSpPr>
+        <a:xfrm>
+          <a:off x="0" y="0"/>
+          <a:ext cx="0" cy="0"/>
+          <a:chOff x="0" y="0"/>
+          <a:chExt cx="0" cy="0"/>
+        </a:xfrm>
+      </p:grpSpPr>
+      <p:sp>
+        <p:nvSpPr>
+          <p:cNvPr id="2" name="Title 1">
+            <a:extLst>
+              <a:ext uri="{FF2B5EF4-FFF2-40B4-BE49-F238E27FC236}">
+                <a16:creationId xmlns:a16="http://schemas.microsoft.com/office/drawing/2014/main" id="{80D820CE-AF93-F8EE-D097-9DF5C08599C2}"/>
+              </a:ext>
+            </a:extLst>
+          </p:cNvPr>
+          <p:cNvSpPr>
+            <a:spLocks noGrp="1"/>
+          </p:cNvSpPr>
+          <p:nvPr>
+            <p:ph type="title"/>
+          </p:nvPr>
+        </p:nvSpPr>
+        <p:spPr>
+          <a:xfrm>
+            <a:off x="2592925" y="624110"/>
+            <a:ext cx="9345550" cy="1280890"/>
+          </a:xfrm>
+        </p:spPr>
+        <p:txBody>
+          <a:bodyPr>
+            <a:normAutofit fontScale="90000"/>
+          </a:bodyPr>
+          <a:lstStyle/>
+          <a:p>
+            <a:r>
+              <a:rPr lang="en-US" dirty="0" err="1"/>
+              <a:t>FieldValidatorAPI</a:t>
+            </a:r>
+            <a:r>
+              <a:rPr lang="en-US" dirty="0"/>
+              <a:t> –</a:t>
+            </a:r>
+            <a:br>
+              <a:rPr lang="en-US" dirty="0"/>
+            </a:br>
+            <a:r>
+              <a:rPr lang="en-US" dirty="0" err="1"/>
+              <a:t>CommonRegularExpressionValidationPatterns</a:t>
+            </a:r>
+            <a:endParaRPr lang="en-US" dirty="0"/>
+          </a:p>
+        </p:txBody>
+      </p:sp>
+      <p:pic>
+        <p:nvPicPr>
+          <p:cNvPr id="5" name="Picture 4">
+            <a:extLst>
+              <a:ext uri="{FF2B5EF4-FFF2-40B4-BE49-F238E27FC236}">
+                <a16:creationId xmlns:a16="http://schemas.microsoft.com/office/drawing/2014/main" id="{9CB6EA87-CF45-3E45-E96C-9E2B62C436F4}"/>
+              </a:ext>
+            </a:extLst>
+          </p:cNvPr>
+          <p:cNvPicPr>
+            <a:picLocks noChangeAspect="1"/>
+          </p:cNvPicPr>
+          <p:nvPr/>
+        </p:nvPicPr>
+        <p:blipFill>
+          <a:blip r:embed="rId2"/>
+          <a:stretch>
+            <a:fillRect/>
+          </a:stretch>
+        </p:blipFill>
+        <p:spPr>
+          <a:xfrm>
+            <a:off x="1143097" y="1878115"/>
+            <a:ext cx="10614905" cy="366935"/>
+          </a:xfrm>
+          <a:prstGeom prst="rect">
+            <a:avLst/>
+          </a:prstGeom>
+        </p:spPr>
+      </p:pic>
+      <p:pic>
+        <p:nvPicPr>
+          <p:cNvPr id="7" name="Picture 6">
+            <a:extLst>
+              <a:ext uri="{FF2B5EF4-FFF2-40B4-BE49-F238E27FC236}">
+                <a16:creationId xmlns:a16="http://schemas.microsoft.com/office/drawing/2014/main" id="{5D346487-26E2-73B7-CBB0-52B843533FA6}"/>
+              </a:ext>
+            </a:extLst>
+          </p:cNvPr>
+          <p:cNvPicPr>
+            <a:picLocks noChangeAspect="1"/>
+          </p:cNvPicPr>
+          <p:nvPr/>
+        </p:nvPicPr>
+        <p:blipFill>
+          <a:blip r:embed="rId3"/>
+          <a:stretch>
+            <a:fillRect/>
+          </a:stretch>
+        </p:blipFill>
+        <p:spPr>
+          <a:xfrm>
+            <a:off x="2592925" y="2372170"/>
+            <a:ext cx="4210050" cy="2124075"/>
+          </a:xfrm>
+          <a:prstGeom prst="rect">
+            <a:avLst/>
+          </a:prstGeom>
+        </p:spPr>
+      </p:pic>
+      <p:pic>
+        <p:nvPicPr>
+          <p:cNvPr id="9" name="Picture 8">
+            <a:extLst>
+              <a:ext uri="{FF2B5EF4-FFF2-40B4-BE49-F238E27FC236}">
+                <a16:creationId xmlns:a16="http://schemas.microsoft.com/office/drawing/2014/main" id="{D93AA2D8-7D89-0824-4428-C29891A635AA}"/>
+              </a:ext>
+            </a:extLst>
+          </p:cNvPr>
+          <p:cNvPicPr>
+            <a:picLocks noChangeAspect="1"/>
+          </p:cNvPicPr>
+          <p:nvPr/>
+        </p:nvPicPr>
+        <p:blipFill>
+          <a:blip r:embed="rId4"/>
+          <a:stretch>
+            <a:fillRect/>
+          </a:stretch>
+        </p:blipFill>
+        <p:spPr>
+          <a:xfrm>
+            <a:off x="6450550" y="5026084"/>
+            <a:ext cx="5048250" cy="923925"/>
+          </a:xfrm>
+          <a:prstGeom prst="rect">
+            <a:avLst/>
+          </a:prstGeom>
+        </p:spPr>
+      </p:pic>
+      <p:sp>
+        <p:nvSpPr>
+          <p:cNvPr id="14" name="Rectangle 13">
+            <a:extLst>
+              <a:ext uri="{FF2B5EF4-FFF2-40B4-BE49-F238E27FC236}">
+                <a16:creationId xmlns:a16="http://schemas.microsoft.com/office/drawing/2014/main" id="{CDDF75AF-9457-4D58-D1B7-4FE7373714AF}"/>
+              </a:ext>
+            </a:extLst>
+          </p:cNvPr>
+          <p:cNvSpPr/>
+          <p:nvPr/>
+        </p:nvSpPr>
+        <p:spPr>
+          <a:xfrm>
+            <a:off x="7588666" y="1887906"/>
+            <a:ext cx="1034042" cy="291272"/>
+          </a:xfrm>
+          <a:prstGeom prst="rect">
+            <a:avLst/>
+          </a:prstGeom>
+          <a:noFill/>
+          <a:ln>
+            <a:solidFill>
+              <a:srgbClr val="FF0000"/>
+            </a:solidFill>
+          </a:ln>
+        </p:spPr>
+        <p:style>
+          <a:lnRef idx="2">
+            <a:schemeClr val="accent1">
+              <a:shade val="15000"/>
+            </a:schemeClr>
+          </a:lnRef>
+          <a:fillRef idx="1">
+            <a:schemeClr val="accent1"/>
+          </a:fillRef>
+          <a:effectRef idx="0">
+            <a:schemeClr val="accent1"/>
+          </a:effectRef>
+          <a:fontRef idx="minor">
+            <a:schemeClr val="lt1"/>
+          </a:fontRef>
+        </p:style>
+        <p:txBody>
+          <a:bodyPr rtlCol="0" anchor="ctr"/>
+          <a:lstStyle/>
+          <a:p>
+            <a:pPr algn="ctr"/>
+            <a:endParaRPr lang="en-US"/>
+          </a:p>
+        </p:txBody>
+      </p:sp>
+      <p:cxnSp>
+        <p:nvCxnSpPr>
+          <p:cNvPr id="16" name="Straight Arrow Connector 15">
+            <a:extLst>
+              <a:ext uri="{FF2B5EF4-FFF2-40B4-BE49-F238E27FC236}">
+                <a16:creationId xmlns:a16="http://schemas.microsoft.com/office/drawing/2014/main" id="{C3F8856E-330D-AFBC-7BD6-45A0A952D287}"/>
+              </a:ext>
+            </a:extLst>
+          </p:cNvPr>
+          <p:cNvCxnSpPr>
+            <a:cxnSpLocks/>
+            <a:stCxn id="14" idx="1"/>
+            <a:endCxn id="7" idx="3"/>
+          </p:cNvCxnSpPr>
+          <p:nvPr/>
+        </p:nvCxnSpPr>
+        <p:spPr>
+          <a:xfrm flipH="1">
+            <a:off x="6802975" y="2033542"/>
+            <a:ext cx="785691" cy="1400666"/>
+          </a:xfrm>
+          <a:prstGeom prst="straightConnector1">
+            <a:avLst/>
+          </a:prstGeom>
+          <a:ln>
+            <a:tailEnd type="triangle"/>
+          </a:ln>
+        </p:spPr>
+        <p:style>
+          <a:lnRef idx="1">
+            <a:schemeClr val="accent1"/>
+          </a:lnRef>
+          <a:fillRef idx="0">
+            <a:schemeClr val="accent1"/>
+          </a:fillRef>
+          <a:effectRef idx="0">
+            <a:schemeClr val="accent1"/>
+          </a:effectRef>
+          <a:fontRef idx="minor">
+            <a:schemeClr val="tx1"/>
+          </a:fontRef>
+        </p:style>
+      </p:cxnSp>
+      <p:cxnSp>
+        <p:nvCxnSpPr>
+          <p:cNvPr id="19" name="Straight Arrow Connector 18">
+            <a:extLst>
+              <a:ext uri="{FF2B5EF4-FFF2-40B4-BE49-F238E27FC236}">
+                <a16:creationId xmlns:a16="http://schemas.microsoft.com/office/drawing/2014/main" id="{F421274C-5FAB-EA44-092C-08BF3C71AD70}"/>
+              </a:ext>
+            </a:extLst>
+          </p:cNvPr>
+          <p:cNvCxnSpPr>
+            <a:cxnSpLocks/>
+            <a:stCxn id="9" idx="0"/>
+          </p:cNvCxnSpPr>
+          <p:nvPr/>
+        </p:nvCxnSpPr>
+        <p:spPr>
+          <a:xfrm flipH="1" flipV="1">
+            <a:off x="8742348" y="2179178"/>
+            <a:ext cx="232327" cy="2846906"/>
+          </a:xfrm>
+          <a:prstGeom prst="straightConnector1">
+            <a:avLst/>
+          </a:prstGeom>
+          <a:ln>
+            <a:tailEnd type="triangle"/>
+          </a:ln>
+        </p:spPr>
+        <p:style>
+          <a:lnRef idx="1">
+            <a:schemeClr val="accent1"/>
+          </a:lnRef>
+          <a:fillRef idx="0">
+            <a:schemeClr val="accent1"/>
+          </a:fillRef>
+          <a:effectRef idx="0">
+            <a:schemeClr val="accent1"/>
+          </a:effectRef>
+          <a:fontRef idx="minor">
+            <a:schemeClr val="tx1"/>
+          </a:fontRef>
+        </p:style>
+      </p:cxnSp>
+    </p:spTree>
+    <p:extLst>
+      <p:ext uri="{BB962C8B-B14F-4D97-AF65-F5344CB8AC3E}">
+        <p14:creationId xmlns:p14="http://schemas.microsoft.com/office/powerpoint/2010/main" val="2532914613"/>
+      </p:ext>
+    </p:extLst>
+  </p:cSld>
+  <p:clrMapOvr>
+    <a:masterClrMapping/>
+  </p:clrMapOvr>
+</p:sld>
+</file>
+
+<file path=ppt/slides/slide15.xml><?xml version="1.0" encoding="utf-8"?>
+<p:sld xmlns:a="http://schemas.openxmlformats.org/drawingml/2006/main" xmlns:r="http://schemas.openxmlformats.org/officeDocument/2006/relationships" xmlns:p="http://schemas.openxmlformats.org/presentationml/2006/main">
+  <p:cSld>
+    <p:spTree>
+      <p:nvGrpSpPr>
+        <p:cNvPr id="1" name=""/>
+        <p:cNvGrpSpPr/>
+        <p:nvPr/>
+      </p:nvGrpSpPr>
+      <p:grpSpPr>
+        <a:xfrm>
+          <a:off x="0" y="0"/>
+          <a:ext cx="0" cy="0"/>
+          <a:chOff x="0" y="0"/>
+          <a:chExt cx="0" cy="0"/>
+        </a:xfrm>
+      </p:grpSpPr>
+      <p:sp>
+        <p:nvSpPr>
+          <p:cNvPr id="4" name="Title 1">
+            <a:extLst>
+              <a:ext uri="{FF2B5EF4-FFF2-40B4-BE49-F238E27FC236}">
+                <a16:creationId xmlns:a16="http://schemas.microsoft.com/office/drawing/2014/main" id="{A6F4ADBC-D316-9E4C-18A0-3D90C2A07E47}"/>
+              </a:ext>
+            </a:extLst>
+          </p:cNvPr>
+          <p:cNvSpPr>
+            <a:spLocks noGrp="1"/>
+          </p:cNvSpPr>
+          <p:nvPr>
+            <p:ph type="title"/>
+          </p:nvPr>
+        </p:nvSpPr>
+        <p:spPr>
+          <a:xfrm>
+            <a:off x="2592388" y="623888"/>
+            <a:ext cx="9380270" cy="1281112"/>
+          </a:xfrm>
+        </p:spPr>
+        <p:txBody>
+          <a:bodyPr>
+            <a:normAutofit fontScale="90000"/>
+          </a:bodyPr>
+          <a:lstStyle/>
+          <a:p>
+            <a:r>
+              <a:rPr lang="en-US" dirty="0" err="1"/>
+              <a:t>FieldValidatorAPI</a:t>
+            </a:r>
+            <a:r>
+              <a:rPr lang="en-US" dirty="0"/>
+              <a:t> –</a:t>
+            </a:r>
+            <a:br>
+              <a:rPr lang="en-US" dirty="0"/>
+            </a:br>
+            <a:r>
+              <a:rPr lang="en-US" dirty="0" err="1"/>
+              <a:t>CommonRegularExpressionValidationPatterns</a:t>
+            </a:r>
+            <a:endParaRPr lang="en-US" dirty="0"/>
+          </a:p>
+        </p:txBody>
+      </p:sp>
+      <p:pic>
+        <p:nvPicPr>
+          <p:cNvPr id="11" name="Picture 10">
+            <a:extLst>
+              <a:ext uri="{FF2B5EF4-FFF2-40B4-BE49-F238E27FC236}">
+                <a16:creationId xmlns:a16="http://schemas.microsoft.com/office/drawing/2014/main" id="{16D268A2-6204-63AE-0316-04E086C492A4}"/>
+              </a:ext>
+            </a:extLst>
+          </p:cNvPr>
+          <p:cNvPicPr>
+            <a:picLocks noChangeAspect="1"/>
+          </p:cNvPicPr>
+          <p:nvPr/>
+        </p:nvPicPr>
+        <p:blipFill>
+          <a:blip r:embed="rId2"/>
+          <a:stretch>
+            <a:fillRect/>
+          </a:stretch>
+        </p:blipFill>
+        <p:spPr>
+          <a:xfrm>
+            <a:off x="1143097" y="2489540"/>
+            <a:ext cx="5857875" cy="1657350"/>
+          </a:xfrm>
+          <a:prstGeom prst="rect">
+            <a:avLst/>
+          </a:prstGeom>
+        </p:spPr>
+      </p:pic>
+      <p:pic>
+        <p:nvPicPr>
+          <p:cNvPr id="13" name="Picture 12">
+            <a:extLst>
+              <a:ext uri="{FF2B5EF4-FFF2-40B4-BE49-F238E27FC236}">
+                <a16:creationId xmlns:a16="http://schemas.microsoft.com/office/drawing/2014/main" id="{D9610273-242D-A303-5585-8B6B121677D8}"/>
+              </a:ext>
+            </a:extLst>
+          </p:cNvPr>
+          <p:cNvPicPr>
+            <a:picLocks noChangeAspect="1"/>
+          </p:cNvPicPr>
+          <p:nvPr/>
+        </p:nvPicPr>
+        <p:blipFill>
+          <a:blip r:embed="rId3"/>
+          <a:stretch>
+            <a:fillRect/>
+          </a:stretch>
+        </p:blipFill>
+        <p:spPr>
+          <a:xfrm>
+            <a:off x="5804877" y="4548187"/>
+            <a:ext cx="5953125" cy="1685925"/>
+          </a:xfrm>
+          <a:prstGeom prst="rect">
+            <a:avLst/>
+          </a:prstGeom>
+        </p:spPr>
+      </p:pic>
+      <p:pic>
+        <p:nvPicPr>
+          <p:cNvPr id="6" name="Picture 5">
+            <a:extLst>
+              <a:ext uri="{FF2B5EF4-FFF2-40B4-BE49-F238E27FC236}">
+                <a16:creationId xmlns:a16="http://schemas.microsoft.com/office/drawing/2014/main" id="{9E6474EE-68AE-5FC5-A247-9553EB870222}"/>
+              </a:ext>
+            </a:extLst>
+          </p:cNvPr>
+          <p:cNvPicPr>
+            <a:picLocks noChangeAspect="1"/>
+          </p:cNvPicPr>
+          <p:nvPr/>
+        </p:nvPicPr>
+        <p:blipFill>
+          <a:blip r:embed="rId4"/>
+          <a:stretch>
+            <a:fillRect/>
+          </a:stretch>
+        </p:blipFill>
+        <p:spPr>
+          <a:xfrm>
+            <a:off x="1143097" y="1878115"/>
+            <a:ext cx="10614905" cy="366935"/>
+          </a:xfrm>
+          <a:prstGeom prst="rect">
+            <a:avLst/>
+          </a:prstGeom>
+        </p:spPr>
+      </p:pic>
+      <p:sp>
+        <p:nvSpPr>
+          <p:cNvPr id="7" name="Rectangle 6">
+            <a:extLst>
+              <a:ext uri="{FF2B5EF4-FFF2-40B4-BE49-F238E27FC236}">
+                <a16:creationId xmlns:a16="http://schemas.microsoft.com/office/drawing/2014/main" id="{AB6C74EB-0E48-0680-8ED2-75519DFA1E9C}"/>
+              </a:ext>
+            </a:extLst>
+          </p:cNvPr>
+          <p:cNvSpPr/>
+          <p:nvPr/>
+        </p:nvSpPr>
+        <p:spPr>
+          <a:xfrm>
+            <a:off x="8793623" y="1878115"/>
+            <a:ext cx="1307506" cy="329103"/>
+          </a:xfrm>
+          <a:prstGeom prst="rect">
+            <a:avLst/>
+          </a:prstGeom>
+          <a:noFill/>
+          <a:ln>
+            <a:solidFill>
+              <a:srgbClr val="FF0000"/>
+            </a:solidFill>
+          </a:ln>
+        </p:spPr>
+        <p:style>
+          <a:lnRef idx="2">
+            <a:schemeClr val="accent1">
+              <a:shade val="15000"/>
+            </a:schemeClr>
+          </a:lnRef>
+          <a:fillRef idx="1">
+            <a:schemeClr val="accent1"/>
+          </a:fillRef>
+          <a:effectRef idx="0">
+            <a:schemeClr val="accent1"/>
+          </a:effectRef>
+          <a:fontRef idx="minor">
+            <a:schemeClr val="lt1"/>
+          </a:fontRef>
+        </p:style>
+        <p:txBody>
+          <a:bodyPr rtlCol="0" anchor="ctr"/>
+          <a:lstStyle/>
+          <a:p>
+            <a:pPr algn="ctr"/>
+            <a:endParaRPr lang="en-US"/>
+          </a:p>
+        </p:txBody>
+      </p:sp>
+      <p:sp>
+        <p:nvSpPr>
+          <p:cNvPr id="8" name="Rectangle 7">
+            <a:extLst>
+              <a:ext uri="{FF2B5EF4-FFF2-40B4-BE49-F238E27FC236}">
+                <a16:creationId xmlns:a16="http://schemas.microsoft.com/office/drawing/2014/main" id="{F266A7A2-16C6-5C3C-EC98-AF3F89D5E1FC}"/>
+              </a:ext>
+            </a:extLst>
+          </p:cNvPr>
+          <p:cNvSpPr/>
+          <p:nvPr/>
+        </p:nvSpPr>
+        <p:spPr>
+          <a:xfrm>
+            <a:off x="10118727" y="1888887"/>
+            <a:ext cx="1307506" cy="329103"/>
+          </a:xfrm>
+          <a:prstGeom prst="rect">
+            <a:avLst/>
+          </a:prstGeom>
+          <a:noFill/>
+          <a:ln>
+            <a:solidFill>
+              <a:srgbClr val="FF0000"/>
+            </a:solidFill>
+          </a:ln>
+        </p:spPr>
+        <p:style>
+          <a:lnRef idx="2">
+            <a:schemeClr val="accent1">
+              <a:shade val="15000"/>
+            </a:schemeClr>
+          </a:lnRef>
+          <a:fillRef idx="1">
+            <a:schemeClr val="accent1"/>
+          </a:fillRef>
+          <a:effectRef idx="0">
+            <a:schemeClr val="accent1"/>
+          </a:effectRef>
+          <a:fontRef idx="minor">
+            <a:schemeClr val="lt1"/>
+          </a:fontRef>
+        </p:style>
+        <p:txBody>
+          <a:bodyPr rtlCol="0" anchor="ctr"/>
+          <a:lstStyle/>
+          <a:p>
+            <a:pPr algn="ctr"/>
+            <a:endParaRPr lang="en-US"/>
+          </a:p>
+        </p:txBody>
+      </p:sp>
+      <p:cxnSp>
+        <p:nvCxnSpPr>
+          <p:cNvPr id="9" name="Straight Arrow Connector 8">
+            <a:extLst>
+              <a:ext uri="{FF2B5EF4-FFF2-40B4-BE49-F238E27FC236}">
+                <a16:creationId xmlns:a16="http://schemas.microsoft.com/office/drawing/2014/main" id="{4CACE865-5A17-F713-AF9B-15B5964563D6}"/>
+              </a:ext>
+            </a:extLst>
+          </p:cNvPr>
+          <p:cNvCxnSpPr>
+            <a:cxnSpLocks/>
+            <a:stCxn id="7" idx="1"/>
+            <a:endCxn id="11" idx="3"/>
+          </p:cNvCxnSpPr>
+          <p:nvPr/>
+        </p:nvCxnSpPr>
+        <p:spPr>
+          <a:xfrm flipH="1">
+            <a:off x="7000972" y="2042667"/>
+            <a:ext cx="1792651" cy="1275548"/>
+          </a:xfrm>
+          <a:prstGeom prst="straightConnector1">
+            <a:avLst/>
+          </a:prstGeom>
+          <a:ln>
+            <a:tailEnd type="triangle"/>
+          </a:ln>
+        </p:spPr>
+        <p:style>
+          <a:lnRef idx="1">
+            <a:schemeClr val="accent1"/>
+          </a:lnRef>
+          <a:fillRef idx="0">
+            <a:schemeClr val="accent1"/>
+          </a:fillRef>
+          <a:effectRef idx="0">
+            <a:schemeClr val="accent1"/>
+          </a:effectRef>
+          <a:fontRef idx="minor">
+            <a:schemeClr val="tx1"/>
+          </a:fontRef>
+        </p:style>
+      </p:cxnSp>
+      <p:cxnSp>
+        <p:nvCxnSpPr>
+          <p:cNvPr id="14" name="Straight Arrow Connector 13">
+            <a:extLst>
+              <a:ext uri="{FF2B5EF4-FFF2-40B4-BE49-F238E27FC236}">
+                <a16:creationId xmlns:a16="http://schemas.microsoft.com/office/drawing/2014/main" id="{07961D08-A493-6011-FA99-A88AF1155CCB}"/>
+              </a:ext>
+            </a:extLst>
+          </p:cNvPr>
+          <p:cNvCxnSpPr>
+            <a:cxnSpLocks/>
+            <a:stCxn id="8" idx="2"/>
+            <a:endCxn id="13" idx="0"/>
+          </p:cNvCxnSpPr>
+          <p:nvPr/>
+        </p:nvCxnSpPr>
+        <p:spPr>
+          <a:xfrm flipH="1">
+            <a:off x="8781440" y="2217990"/>
+            <a:ext cx="1991040" cy="2330197"/>
+          </a:xfrm>
+          <a:prstGeom prst="straightConnector1">
+            <a:avLst/>
+          </a:prstGeom>
+          <a:ln>
+            <a:tailEnd type="triangle"/>
+          </a:ln>
+        </p:spPr>
+        <p:style>
+          <a:lnRef idx="1">
+            <a:schemeClr val="accent1"/>
+          </a:lnRef>
+          <a:fillRef idx="0">
+            <a:schemeClr val="accent1"/>
+          </a:fillRef>
+          <a:effectRef idx="0">
+            <a:schemeClr val="accent1"/>
+          </a:effectRef>
+          <a:fontRef idx="minor">
+            <a:schemeClr val="tx1"/>
+          </a:fontRef>
+        </p:style>
+      </p:cxnSp>
+    </p:spTree>
+    <p:extLst>
+      <p:ext uri="{BB962C8B-B14F-4D97-AF65-F5344CB8AC3E}">
+        <p14:creationId xmlns:p14="http://schemas.microsoft.com/office/powerpoint/2010/main" val="3434693411"/>
+      </p:ext>
+    </p:extLst>
+  </p:cSld>
+  <p:clrMapOvr>
+    <a:masterClrMapping/>
+  </p:clrMapOvr>
+</p:sld>
+</file>
+
+<file path=ppt/slides/slide16.xml><?xml version="1.0" encoding="utf-8"?>
+<p:sld xmlns:a="http://schemas.openxmlformats.org/drawingml/2006/main" xmlns:r="http://schemas.openxmlformats.org/officeDocument/2006/relationships" xmlns:p="http://schemas.openxmlformats.org/presentationml/2006/main">
+  <p:cSld>
+    <p:spTree>
+      <p:nvGrpSpPr>
+        <p:cNvPr id="1" name=""/>
+        <p:cNvGrpSpPr/>
+        <p:nvPr/>
+      </p:nvGrpSpPr>
+      <p:grpSpPr>
+        <a:xfrm>
+          <a:off x="0" y="0"/>
+          <a:ext cx="0" cy="0"/>
+          <a:chOff x="0" y="0"/>
+          <a:chExt cx="0" cy="0"/>
+        </a:xfrm>
+      </p:grpSpPr>
+      <p:sp>
+        <p:nvSpPr>
+          <p:cNvPr id="6" name="Title 1">
+            <a:extLst>
+              <a:ext uri="{FF2B5EF4-FFF2-40B4-BE49-F238E27FC236}">
+                <a16:creationId xmlns:a16="http://schemas.microsoft.com/office/drawing/2014/main" id="{4A479802-021E-02D1-FCE6-2284A16EAA39}"/>
+              </a:ext>
+            </a:extLst>
+          </p:cNvPr>
+          <p:cNvSpPr>
+            <a:spLocks noGrp="1"/>
+          </p:cNvSpPr>
+          <p:nvPr>
+            <p:ph type="title"/>
+          </p:nvPr>
+        </p:nvSpPr>
+        <p:spPr>
+          <a:xfrm>
+            <a:off x="2592388" y="623888"/>
+            <a:ext cx="9209354" cy="1281112"/>
+          </a:xfrm>
+        </p:spPr>
+        <p:txBody>
+          <a:bodyPr>
+            <a:normAutofit fontScale="90000"/>
+          </a:bodyPr>
+          <a:lstStyle/>
+          <a:p>
+            <a:r>
+              <a:rPr lang="en-US" dirty="0" err="1"/>
+              <a:t>FieldValidatorAPI</a:t>
+            </a:r>
+            <a:r>
+              <a:rPr lang="en-US" dirty="0"/>
+              <a:t> –</a:t>
+            </a:r>
+            <a:br>
+              <a:rPr lang="en-US" dirty="0"/>
+            </a:br>
+            <a:r>
+              <a:rPr lang="en-US" dirty="0" err="1"/>
+              <a:t>CommonRegularExpressionValidationPatterns</a:t>
+            </a:r>
+            <a:endParaRPr lang="en-US" dirty="0"/>
+          </a:p>
+        </p:txBody>
+      </p:sp>
+      <p:pic>
+        <p:nvPicPr>
+          <p:cNvPr id="8" name="Picture 7">
+            <a:extLst>
+              <a:ext uri="{FF2B5EF4-FFF2-40B4-BE49-F238E27FC236}">
+                <a16:creationId xmlns:a16="http://schemas.microsoft.com/office/drawing/2014/main" id="{06888162-382B-9B42-3B26-E1057F5FAC69}"/>
+              </a:ext>
+            </a:extLst>
+          </p:cNvPr>
+          <p:cNvPicPr>
+            <a:picLocks noChangeAspect="1"/>
+          </p:cNvPicPr>
+          <p:nvPr/>
+        </p:nvPicPr>
+        <p:blipFill>
+          <a:blip r:embed="rId2"/>
+          <a:stretch>
+            <a:fillRect/>
+          </a:stretch>
+        </p:blipFill>
+        <p:spPr>
+          <a:xfrm>
+            <a:off x="2744402" y="2371992"/>
+            <a:ext cx="5934075" cy="1943100"/>
+          </a:xfrm>
+          <a:prstGeom prst="rect">
+            <a:avLst/>
+          </a:prstGeom>
+        </p:spPr>
+      </p:pic>
+      <p:pic>
+        <p:nvPicPr>
+          <p:cNvPr id="10" name="Picture 9">
+            <a:extLst>
+              <a:ext uri="{FF2B5EF4-FFF2-40B4-BE49-F238E27FC236}">
+                <a16:creationId xmlns:a16="http://schemas.microsoft.com/office/drawing/2014/main" id="{3D0E6B46-8E58-4C28-623A-F40451DE4C4E}"/>
+              </a:ext>
+            </a:extLst>
+          </p:cNvPr>
+          <p:cNvPicPr>
+            <a:picLocks noChangeAspect="1"/>
+          </p:cNvPicPr>
+          <p:nvPr/>
+        </p:nvPicPr>
+        <p:blipFill>
+          <a:blip r:embed="rId3"/>
+          <a:stretch>
+            <a:fillRect/>
+          </a:stretch>
+        </p:blipFill>
+        <p:spPr>
+          <a:xfrm>
+            <a:off x="1035421" y="1732704"/>
+            <a:ext cx="10670014" cy="344591"/>
+          </a:xfrm>
+          <a:prstGeom prst="rect">
+            <a:avLst/>
+          </a:prstGeom>
+        </p:spPr>
+      </p:pic>
+      <p:sp>
+        <p:nvSpPr>
+          <p:cNvPr id="11" name="TextBox 10">
+            <a:extLst>
+              <a:ext uri="{FF2B5EF4-FFF2-40B4-BE49-F238E27FC236}">
+                <a16:creationId xmlns:a16="http://schemas.microsoft.com/office/drawing/2014/main" id="{68786D2E-E2EF-FBD8-796E-5FEC0F6F1C11}"/>
+              </a:ext>
+            </a:extLst>
+          </p:cNvPr>
+          <p:cNvSpPr txBox="1"/>
+          <p:nvPr/>
+        </p:nvSpPr>
+        <p:spPr>
+          <a:xfrm>
+            <a:off x="2744402" y="4609789"/>
+            <a:ext cx="4305987" cy="646331"/>
+          </a:xfrm>
+          <a:prstGeom prst="rect">
+            <a:avLst/>
+          </a:prstGeom>
+          <a:noFill/>
+        </p:spPr>
+        <p:txBody>
+          <a:bodyPr wrap="none" rtlCol="0">
+            <a:spAutoFit/>
+          </a:bodyPr>
+          <a:lstStyle/>
+          <a:p>
+            <a:r>
+              <a:rPr lang="en-US" dirty="0"/>
+              <a:t>-? Means allow zero or one hyphens</a:t>
+            </a:r>
+          </a:p>
+          <a:p>
+            <a:r>
+              <a:rPr lang="en-US" dirty="0"/>
+              <a:t>-* Means allow zero or more hyphens</a:t>
+            </a:r>
+          </a:p>
+        </p:txBody>
+      </p:sp>
+    </p:spTree>
+    <p:extLst>
+      <p:ext uri="{BB962C8B-B14F-4D97-AF65-F5344CB8AC3E}">
+        <p14:creationId xmlns:p14="http://schemas.microsoft.com/office/powerpoint/2010/main" val="1949856186"/>
+      </p:ext>
+    </p:extLst>
+  </p:cSld>
+  <p:clrMapOvr>
+    <a:masterClrMapping/>
+  </p:clrMapOvr>
+</p:sld>
+</file>
+
+<file path=ppt/slides/slide17.xml><?xml version="1.0" encoding="utf-8"?>
+<p:sld xmlns:a="http://schemas.openxmlformats.org/drawingml/2006/main" xmlns:r="http://schemas.openxmlformats.org/officeDocument/2006/relationships" xmlns:p="http://schemas.openxmlformats.org/presentationml/2006/main">
+  <p:cSld>
+    <p:spTree>
+      <p:nvGrpSpPr>
+        <p:cNvPr id="1" name=""/>
+        <p:cNvGrpSpPr/>
+        <p:nvPr/>
+      </p:nvGrpSpPr>
+      <p:grpSpPr>
+        <a:xfrm>
+          <a:off x="0" y="0"/>
+          <a:ext cx="0" cy="0"/>
+          <a:chOff x="0" y="0"/>
+          <a:chExt cx="0" cy="0"/>
+        </a:xfrm>
+      </p:grpSpPr>
+      <p:sp>
+        <p:nvSpPr>
+          <p:cNvPr id="6" name="Title 1">
+            <a:extLst>
+              <a:ext uri="{FF2B5EF4-FFF2-40B4-BE49-F238E27FC236}">
+                <a16:creationId xmlns:a16="http://schemas.microsoft.com/office/drawing/2014/main" id="{4A479802-021E-02D1-FCE6-2284A16EAA39}"/>
+              </a:ext>
+            </a:extLst>
+          </p:cNvPr>
+          <p:cNvSpPr>
+            <a:spLocks noGrp="1"/>
+          </p:cNvSpPr>
+          <p:nvPr>
+            <p:ph type="title"/>
+          </p:nvPr>
+        </p:nvSpPr>
+        <p:spPr>
+          <a:xfrm>
+            <a:off x="2592388" y="623888"/>
+            <a:ext cx="9209354" cy="1281112"/>
+          </a:xfrm>
+        </p:spPr>
+        <p:txBody>
+          <a:bodyPr>
+            <a:normAutofit fontScale="90000"/>
+          </a:bodyPr>
+          <a:lstStyle/>
+          <a:p>
+            <a:r>
+              <a:rPr lang="en-US" dirty="0" err="1"/>
+              <a:t>FieldValidatorAPI</a:t>
+            </a:r>
+            <a:r>
+              <a:rPr lang="en-US" dirty="0"/>
+              <a:t> –</a:t>
+            </a:r>
+            <a:br>
+              <a:rPr lang="en-US" dirty="0"/>
+            </a:br>
+            <a:r>
+              <a:rPr lang="en-US" dirty="0" err="1"/>
+              <a:t>CommonRegularExpressionValidationPatterns</a:t>
+            </a:r>
+            <a:endParaRPr lang="en-US" dirty="0"/>
+          </a:p>
+        </p:txBody>
+      </p:sp>
+      <p:pic>
+        <p:nvPicPr>
+          <p:cNvPr id="4" name="Picture 3">
+            <a:extLst>
+              <a:ext uri="{FF2B5EF4-FFF2-40B4-BE49-F238E27FC236}">
+                <a16:creationId xmlns:a16="http://schemas.microsoft.com/office/drawing/2014/main" id="{18BCC662-9B25-8368-4D93-CEF1DB2B5E86}"/>
+              </a:ext>
+            </a:extLst>
+          </p:cNvPr>
+          <p:cNvPicPr>
+            <a:picLocks noChangeAspect="1"/>
+          </p:cNvPicPr>
+          <p:nvPr/>
+        </p:nvPicPr>
+        <p:blipFill>
+          <a:blip r:embed="rId2"/>
+          <a:stretch>
+            <a:fillRect/>
+          </a:stretch>
+        </p:blipFill>
+        <p:spPr>
+          <a:xfrm>
+            <a:off x="2215364" y="1810996"/>
+            <a:ext cx="8299371" cy="393819"/>
+          </a:xfrm>
+          <a:prstGeom prst="rect">
+            <a:avLst/>
+          </a:prstGeom>
+        </p:spPr>
+      </p:pic>
+      <p:pic>
+        <p:nvPicPr>
+          <p:cNvPr id="8" name="Picture 7">
+            <a:extLst>
+              <a:ext uri="{FF2B5EF4-FFF2-40B4-BE49-F238E27FC236}">
+                <a16:creationId xmlns:a16="http://schemas.microsoft.com/office/drawing/2014/main" id="{101DC7FC-6ABB-C2F1-ED0F-B753EB893950}"/>
+              </a:ext>
+            </a:extLst>
+          </p:cNvPr>
+          <p:cNvPicPr>
+            <a:picLocks noChangeAspect="1"/>
+          </p:cNvPicPr>
+          <p:nvPr/>
+        </p:nvPicPr>
+        <p:blipFill>
+          <a:blip r:embed="rId3"/>
+          <a:stretch>
+            <a:fillRect/>
+          </a:stretch>
+        </p:blipFill>
+        <p:spPr>
+          <a:xfrm>
+            <a:off x="2753926" y="2483843"/>
+            <a:ext cx="4086225" cy="847725"/>
+          </a:xfrm>
+          <a:prstGeom prst="rect">
+            <a:avLst/>
+          </a:prstGeom>
+        </p:spPr>
+      </p:pic>
+      <p:sp>
+        <p:nvSpPr>
+          <p:cNvPr id="9" name="TextBox 8">
+            <a:extLst>
+              <a:ext uri="{FF2B5EF4-FFF2-40B4-BE49-F238E27FC236}">
+                <a16:creationId xmlns:a16="http://schemas.microsoft.com/office/drawing/2014/main" id="{7865FC97-50FC-498D-737B-97239A641D17}"/>
+              </a:ext>
+            </a:extLst>
+          </p:cNvPr>
+          <p:cNvSpPr txBox="1"/>
+          <p:nvPr/>
+        </p:nvSpPr>
+        <p:spPr>
+          <a:xfrm>
+            <a:off x="2215364" y="3391923"/>
+            <a:ext cx="9584675" cy="1200329"/>
+          </a:xfrm>
+          <a:prstGeom prst="rect">
+            <a:avLst/>
+          </a:prstGeom>
+          <a:noFill/>
+        </p:spPr>
+        <p:txBody>
+          <a:bodyPr wrap="none" rtlCol="0">
+            <a:spAutoFit/>
+          </a:bodyPr>
+          <a:lstStyle/>
+          <a:p>
+            <a:r>
+              <a:rPr lang="en-US" dirty="0"/>
+              <a:t>Without ^ and $ , </a:t>
+            </a:r>
+          </a:p>
+          <a:p>
+            <a:r>
+              <a:rPr lang="en-US" dirty="0"/>
+              <a:t>user can enter more than 5 digits or as long as there were 5 digits match in between</a:t>
+            </a:r>
+          </a:p>
+          <a:p>
+            <a:endParaRPr lang="en-US" dirty="0"/>
+          </a:p>
+          <a:p>
+            <a:r>
+              <a:rPr lang="en-US" dirty="0"/>
+              <a:t>^ and $ are known as Anchors</a:t>
+            </a:r>
+          </a:p>
+        </p:txBody>
+      </p:sp>
+    </p:spTree>
+    <p:extLst>
+      <p:ext uri="{BB962C8B-B14F-4D97-AF65-F5344CB8AC3E}">
+        <p14:creationId xmlns:p14="http://schemas.microsoft.com/office/powerpoint/2010/main" val="3076793354"/>
+      </p:ext>
+    </p:extLst>
+  </p:cSld>
+  <p:clrMapOvr>
+    <a:masterClrMapping/>
+  </p:clrMapOvr>
+</p:sld>
+</file>
+
+<file path=ppt/slides/slide18.xml><?xml version="1.0" encoding="utf-8"?>
+<p:sld xmlns:a="http://schemas.openxmlformats.org/drawingml/2006/main" xmlns:r="http://schemas.openxmlformats.org/officeDocument/2006/relationships" xmlns:p="http://schemas.openxmlformats.org/presentationml/2006/main">
+  <p:cSld>
+    <p:spTree>
+      <p:nvGrpSpPr>
+        <p:cNvPr id="1" name=""/>
+        <p:cNvGrpSpPr/>
+        <p:nvPr/>
+      </p:nvGrpSpPr>
+      <p:grpSpPr>
+        <a:xfrm>
+          <a:off x="0" y="0"/>
+          <a:ext cx="0" cy="0"/>
+          <a:chOff x="0" y="0"/>
+          <a:chExt cx="0" cy="0"/>
+        </a:xfrm>
+      </p:grpSpPr>
+      <p:sp>
+        <p:nvSpPr>
+          <p:cNvPr id="6" name="Title 1">
+            <a:extLst>
+              <a:ext uri="{FF2B5EF4-FFF2-40B4-BE49-F238E27FC236}">
+                <a16:creationId xmlns:a16="http://schemas.microsoft.com/office/drawing/2014/main" id="{4A479802-021E-02D1-FCE6-2284A16EAA39}"/>
+              </a:ext>
+            </a:extLst>
+          </p:cNvPr>
+          <p:cNvSpPr>
+            <a:spLocks noGrp="1"/>
+          </p:cNvSpPr>
+          <p:nvPr>
+            <p:ph type="title"/>
+          </p:nvPr>
+        </p:nvSpPr>
+        <p:spPr>
+          <a:xfrm>
+            <a:off x="2592388" y="623888"/>
+            <a:ext cx="9209354" cy="1281112"/>
+          </a:xfrm>
+        </p:spPr>
+        <p:txBody>
+          <a:bodyPr>
+            <a:normAutofit fontScale="90000"/>
+          </a:bodyPr>
+          <a:lstStyle/>
+          <a:p>
+            <a:r>
+              <a:rPr lang="en-US" dirty="0" err="1"/>
+              <a:t>FieldValidatorAPI</a:t>
+            </a:r>
+            <a:r>
+              <a:rPr lang="en-US" dirty="0"/>
+              <a:t> –</a:t>
+            </a:r>
+            <a:br>
+              <a:rPr lang="en-US" dirty="0"/>
+            </a:br>
+            <a:r>
+              <a:rPr lang="en-US" dirty="0" err="1"/>
+              <a:t>CommonRegularExpressionValidationPatterns</a:t>
+            </a:r>
+            <a:endParaRPr lang="en-US" dirty="0"/>
+          </a:p>
+        </p:txBody>
+      </p:sp>
+      <p:pic>
+        <p:nvPicPr>
+          <p:cNvPr id="4" name="Picture 3">
+            <a:extLst>
+              <a:ext uri="{FF2B5EF4-FFF2-40B4-BE49-F238E27FC236}">
+                <a16:creationId xmlns:a16="http://schemas.microsoft.com/office/drawing/2014/main" id="{A7ECDD73-E201-6727-E5DC-8A911308DB60}"/>
+              </a:ext>
+            </a:extLst>
+          </p:cNvPr>
+          <p:cNvPicPr>
+            <a:picLocks noChangeAspect="1"/>
+          </p:cNvPicPr>
+          <p:nvPr/>
+        </p:nvPicPr>
+        <p:blipFill>
+          <a:blip r:embed="rId2"/>
+          <a:stretch>
+            <a:fillRect/>
+          </a:stretch>
+        </p:blipFill>
+        <p:spPr>
+          <a:xfrm>
+            <a:off x="133350" y="1638300"/>
+            <a:ext cx="12058650" cy="266700"/>
+          </a:xfrm>
+          <a:prstGeom prst="rect">
+            <a:avLst/>
+          </a:prstGeom>
+        </p:spPr>
+      </p:pic>
+      <p:pic>
+        <p:nvPicPr>
+          <p:cNvPr id="7" name="Picture 6">
+            <a:extLst>
+              <a:ext uri="{FF2B5EF4-FFF2-40B4-BE49-F238E27FC236}">
+                <a16:creationId xmlns:a16="http://schemas.microsoft.com/office/drawing/2014/main" id="{E96FF8F9-8B80-4A23-C9B0-7A9F57292957}"/>
+              </a:ext>
+            </a:extLst>
+          </p:cNvPr>
+          <p:cNvPicPr>
+            <a:picLocks noChangeAspect="1"/>
+          </p:cNvPicPr>
+          <p:nvPr/>
+        </p:nvPicPr>
+        <p:blipFill>
+          <a:blip r:embed="rId3"/>
+          <a:stretch>
+            <a:fillRect/>
+          </a:stretch>
+        </p:blipFill>
+        <p:spPr>
+          <a:xfrm>
+            <a:off x="447141" y="2178777"/>
+            <a:ext cx="6153150" cy="3457575"/>
+          </a:xfrm>
+          <a:prstGeom prst="rect">
+            <a:avLst/>
+          </a:prstGeom>
+        </p:spPr>
+      </p:pic>
+      <p:sp>
+        <p:nvSpPr>
+          <p:cNvPr id="8" name="TextBox 7">
+            <a:extLst>
+              <a:ext uri="{FF2B5EF4-FFF2-40B4-BE49-F238E27FC236}">
+                <a16:creationId xmlns:a16="http://schemas.microsoft.com/office/drawing/2014/main" id="{144F1E57-74E2-6FA3-BE41-6232CD7077AF}"/>
+              </a:ext>
+            </a:extLst>
+          </p:cNvPr>
+          <p:cNvSpPr txBox="1"/>
+          <p:nvPr/>
+        </p:nvSpPr>
+        <p:spPr>
+          <a:xfrm>
+            <a:off x="6752379" y="2273081"/>
+            <a:ext cx="5521063" cy="646331"/>
+          </a:xfrm>
+          <a:prstGeom prst="rect">
+            <a:avLst/>
+          </a:prstGeom>
+          <a:noFill/>
+        </p:spPr>
+        <p:txBody>
+          <a:bodyPr wrap="none" rtlCol="0">
+            <a:spAutoFit/>
+          </a:bodyPr>
+          <a:lstStyle/>
+          <a:p>
+            <a:r>
+              <a:rPr lang="en-US" dirty="0"/>
+              <a:t>?= is the Lookahead syntax.</a:t>
+            </a:r>
+          </a:p>
+          <a:p>
+            <a:r>
+              <a:rPr lang="en-US" dirty="0"/>
+              <a:t>.* means any character appear 0 or more times</a:t>
+            </a:r>
+          </a:p>
+        </p:txBody>
+      </p:sp>
+      <p:pic>
+        <p:nvPicPr>
+          <p:cNvPr id="10" name="Picture 9">
+            <a:extLst>
+              <a:ext uri="{FF2B5EF4-FFF2-40B4-BE49-F238E27FC236}">
+                <a16:creationId xmlns:a16="http://schemas.microsoft.com/office/drawing/2014/main" id="{2C9D7986-F11C-2FFB-2296-DF4C040F01D7}"/>
+              </a:ext>
+            </a:extLst>
+          </p:cNvPr>
+          <p:cNvPicPr>
+            <a:picLocks noChangeAspect="1"/>
+          </p:cNvPicPr>
+          <p:nvPr/>
+        </p:nvPicPr>
+        <p:blipFill>
+          <a:blip r:embed="rId4"/>
+          <a:stretch>
+            <a:fillRect/>
+          </a:stretch>
+        </p:blipFill>
+        <p:spPr>
+          <a:xfrm>
+            <a:off x="7346668" y="3255101"/>
+            <a:ext cx="4181475" cy="1304925"/>
+          </a:xfrm>
+          <a:prstGeom prst="rect">
+            <a:avLst/>
+          </a:prstGeom>
+        </p:spPr>
+      </p:pic>
+    </p:spTree>
+    <p:extLst>
+      <p:ext uri="{BB962C8B-B14F-4D97-AF65-F5344CB8AC3E}">
+        <p14:creationId xmlns:p14="http://schemas.microsoft.com/office/powerpoint/2010/main" val="2752992060"/>
       </p:ext>
     </p:extLst>
   </p:cSld>

</xml_diff>